<commit_message>
feat: update booking link to cal.com/collins-collins-h1q7yn/30min
Replaced selll.io/audit with live Cal.com link across:
- QRFloorGenie-Disco-Deck.pptx (slides 1 + 13)
- MagmaLabs-Disco-Deck.pptx (slides 1 + 13)
- MagmaLabs-FollowUp-Email.txt
- disco_processor.py (email template + deck)
- selll-signature-full.jpg (booking link now visible in gold)

Co-Authored-By: Claude Sonnet 4.6 <noreply@anthropic.com>
</commit_message>
<xml_diff>
--- a/SELLL-Engine/MagmaLabs-Disco-Deck.pptx
+++ b/SELLL-Engine/MagmaLabs-Disco-Deck.pptx
@@ -4171,7 +4171,7 @@
                   <a:srgbClr val="888899"/>
                 </a:solidFill>
               </a:rPr>
-              <a:t>SELLL.io  |  Signal-Intelligent Revenue Engine  |  selll.io/audit</a:t>
+              <a:t>SELLL.io  |  Signal-Intelligent Revenue Engine  |  cal.com/collins-collins-h1q7yn/30min</a:t>
             </a:r>
           </a:p>
         </p:txBody>
@@ -9421,7 +9421,7 @@
                   <a:srgbClr val="1A1A2E"/>
                 </a:solidFill>
               </a:rPr>
-              <a:t>Ready to start?  Reply to this email  or  book at  selll.io/audit</a:t>
+              <a:t>Ready to start?  Reply to this email  or  book at  cal.com/collins-collins-h1q7yn/30min</a:t>
             </a:r>
           </a:p>
         </p:txBody>

</xml_diff>

<commit_message>
fix: update all booking links to correct Cal.com URL
Replace cal.com/collins-collins-h1q7yn/30min with cal.com/collins-ogiki-x4fokk/30min
across all materials -- both PPTX decks rebuilt, signature strip regenerated,
email templates and disco_processor.py updated.

Co-Authored-By: Claude Sonnet 4.6 <noreply@anthropic.com>
</commit_message>
<xml_diff>
--- a/SELLL-Engine/MagmaLabs-Disco-Deck.pptx
+++ b/SELLL-Engine/MagmaLabs-Disco-Deck.pptx
@@ -4171,7 +4171,7 @@
                   <a:srgbClr val="888899"/>
                 </a:solidFill>
               </a:rPr>
-              <a:t>SELLL.io  |  Signal-Intelligent Revenue Engine  |  cal.com/collins-collins-h1q7yn/30min</a:t>
+              <a:t>SELLL.io  |  Signal-Intelligent Revenue Engine  |  cal.com/collins-ogiki-x4fokk/30min</a:t>
             </a:r>
           </a:p>
         </p:txBody>
@@ -9421,7 +9421,7 @@
                   <a:srgbClr val="1A1A2E"/>
                 </a:solidFill>
               </a:rPr>
-              <a:t>Ready to start?  Reply to this email  or  book at  cal.com/collins-collins-h1q7yn/30min</a:t>
+              <a:t>Ready to start?  Reply to this email  or  book at  cal.com/collins-ogiki-x4fokk/30min</a:t>
             </a:r>
           </a:p>
         </p:txBody>

</xml_diff>